<commit_message>
발표자료: HPWD-GPT → HPWD AI Agent로 명칭 변경
- 표지 타이틀 두 줄 표시 (HPWD / AI Agent)
- 본문 5곳 일괄 변경
- PPT cover 레이아웃 조정 (line spacing 1.05, tagline 위치 조정)
</commit_message>
<xml_diff>
--- a/public/HPWD-GPT.pptx
+++ b/public/HPWD-GPT.pptx
@@ -3159,8 +3159,8 @@
         </p:nvSpPr>
         <p:spPr>
           <a:xfrm>
-            <a:off x="548640" y="1371600"/>
-            <a:ext cx="10972800" cy="2286000"/>
+            <a:off x="548640" y="1188720"/>
+            <a:ext cx="10972800" cy="2926080"/>
           </a:xfrm>
           <a:prstGeom prst="rect">
             <a:avLst/>
@@ -3175,7 +3175,7 @@
           <a:p>
             <a:pPr algn="l">
               <a:lnSpc>
-                <a:spcPct val="100000"/>
+                <a:spcPct val="105000"/>
               </a:lnSpc>
             </a:pPr>
             <a:r>
@@ -3185,7 +3185,23 @@
                 </a:solidFill>
                 <a:latin typeface="Pretendard"/>
               </a:rPr>
-              <a:t>HPWD-GPT</a:t>
+              <a:t>HPWD</a:t>
+            </a:r>
+          </a:p>
+          <a:p>
+            <a:pPr algn="l">
+              <a:lnSpc>
+                <a:spcPct val="105000"/>
+              </a:lnSpc>
+            </a:pPr>
+            <a:r>
+              <a:rPr sz="9600" b="1" i="0">
+                <a:solidFill>
+                  <a:srgbClr val="FFFFFF"/>
+                </a:solidFill>
+                <a:latin typeface="Pretendard"/>
+              </a:rPr>
+              <a:t>AI Agent</a:t>
             </a:r>
           </a:p>
         </p:txBody>
@@ -3198,8 +3214,8 @@
         </p:nvSpPr>
         <p:spPr>
           <a:xfrm>
-            <a:off x="548640" y="4023360"/>
-            <a:ext cx="10058400" cy="1371600"/>
+            <a:off x="548640" y="4297680"/>
+            <a:ext cx="10058400" cy="914400"/>
           </a:xfrm>
           <a:prstGeom prst="rect">
             <a:avLst/>
@@ -19456,7 +19472,7 @@
                 </a:solidFill>
                 <a:latin typeface="Pretendard"/>
               </a:rPr>
-              <a:t>비전문가 사용 가능성 = HPWD-GPT 차별점</a:t>
+              <a:t>비전문가 사용 가능성 = HPWD AI Agent 차별점</a:t>
             </a:r>
           </a:p>
           <a:p>

</xml_diff>